<commit_message>
feat(presentation): fix diagram frame overflows + add A4 project report (TNR 14, <=15 pages)
- PPTX: shrink long glyph-chip labels (S5/S6/S7/S8), widen layer chips, keep >=16pt, no overlaps (geometry-audited)
- New: generate-baocao.mjs builds 20_BaoCao_ThucHien_DuAn.docx/.md — A4, left 3cm/right 2cm/top 2cm/bottom 2cm, single spacing, Times New Roman 14pt, 7 pages (Word-verified), follows engineering-project rubric (Vấn đề / Thiết kế & phương pháp / Chế tạo & kiểm tra)
- New: 02_Presentation.pdf rendered via PowerPoint COM (15 pages); docs/manifest updated; report PDF pending Word/LibreOffice
</commit_message>
<xml_diff>
--- a/dist/presentation/01_EduChoice-AI_Presentation.pptx
+++ b/dist/presentation/01_EduChoice-AI_Presentation.pptx
@@ -19558,7 +19558,7 @@
         <p:spPr>
           <a:xfrm>
             <a:off x="548640" y="5166360"/>
-            <a:ext cx="1554480" cy="457200"/>
+            <a:ext cx="1737360" cy="457200"/>
           </a:xfrm>
           <a:prstGeom prst="roundRect">
             <a:avLst>
@@ -19624,7 +19624,7 @@
         <p:spPr>
           <a:xfrm>
             <a:off x="1097280" y="5166360"/>
-            <a:ext cx="969264" cy="457200"/>
+            <a:ext cx="1152144" cy="457200"/>
           </a:xfrm>
           <a:prstGeom prst="rect">
             <a:avLst/>
@@ -19667,8 +19667,8 @@
         </p:nvSpPr>
         <p:spPr>
           <a:xfrm>
-            <a:off x="2148840" y="5001768"/>
-            <a:ext cx="1737360" cy="822960"/>
+            <a:off x="2331720" y="5001768"/>
+            <a:ext cx="1554480" cy="822960"/>
           </a:xfrm>
           <a:prstGeom prst="rect">
             <a:avLst/>
@@ -19739,7 +19739,7 @@
         <p:spPr>
           <a:xfrm>
             <a:off x="4352544" y="5166360"/>
-            <a:ext cx="1554480" cy="457200"/>
+            <a:ext cx="1737360" cy="457200"/>
           </a:xfrm>
           <a:prstGeom prst="roundRect">
             <a:avLst>
@@ -19805,7 +19805,7 @@
         <p:spPr>
           <a:xfrm>
             <a:off x="4901184" y="5166360"/>
-            <a:ext cx="969264" cy="457200"/>
+            <a:ext cx="1152144" cy="457200"/>
           </a:xfrm>
           <a:prstGeom prst="rect">
             <a:avLst/>
@@ -19848,8 +19848,8 @@
         </p:nvSpPr>
         <p:spPr>
           <a:xfrm>
-            <a:off x="5952744" y="5001768"/>
-            <a:ext cx="1737360" cy="822960"/>
+            <a:off x="6135624" y="5001768"/>
+            <a:ext cx="1554480" cy="822960"/>
           </a:xfrm>
           <a:prstGeom prst="rect">
             <a:avLst/>
@@ -19920,7 +19920,7 @@
         <p:spPr>
           <a:xfrm>
             <a:off x="8156448" y="5166360"/>
-            <a:ext cx="1554480" cy="457200"/>
+            <a:ext cx="1737360" cy="457200"/>
           </a:xfrm>
           <a:prstGeom prst="roundRect">
             <a:avLst>
@@ -19986,7 +19986,7 @@
         <p:spPr>
           <a:xfrm>
             <a:off x="8705088" y="5166360"/>
-            <a:ext cx="969264" cy="457200"/>
+            <a:ext cx="1152144" cy="457200"/>
           </a:xfrm>
           <a:prstGeom prst="rect">
             <a:avLst/>
@@ -20015,7 +20015,7 @@
                 <a:ea typeface="Times New Roman" pitchFamily="34" charset="-122"/>
                 <a:cs typeface="Times New Roman" pitchFamily="34" charset="-120"/>
               </a:rPr>
-              <a:t>Transfer đo được</a:t>
+              <a:t>Transfer</a:t>
             </a:r>
             <a:endParaRPr lang="en-US" sz="1600" dirty="0"/>
           </a:p>
@@ -20029,8 +20029,8 @@
         </p:nvSpPr>
         <p:spPr>
           <a:xfrm>
-            <a:off x="9756648" y="5001768"/>
-            <a:ext cx="1737360" cy="822960"/>
+            <a:off x="9939528" y="5001768"/>
+            <a:ext cx="1554480" cy="822960"/>
           </a:xfrm>
           <a:prstGeom prst="rect">
             <a:avLst/>
@@ -20384,7 +20384,7 @@
         <p:spPr>
           <a:xfrm>
             <a:off x="576072" y="1792224"/>
-            <a:ext cx="2651760" cy="530352"/>
+            <a:ext cx="3017520" cy="530352"/>
           </a:xfrm>
           <a:prstGeom prst="roundRect">
             <a:avLst>
@@ -20450,7 +20450,7 @@
         <p:spPr>
           <a:xfrm>
             <a:off x="1197864" y="1792224"/>
-            <a:ext cx="1993392" cy="530352"/>
+            <a:ext cx="2359152" cy="530352"/>
           </a:xfrm>
           <a:prstGeom prst="rect">
             <a:avLst/>
@@ -20471,7 +20471,7 @@
               <a:buNone/>
             </a:pPr>
             <a:r>
-              <a:rPr lang="en-US" sz="1800" b="1" dirty="0">
+              <a:rPr lang="en-US" sz="1700" b="1" dirty="0">
                 <a:solidFill>
                   <a:srgbClr val="1E2440"/>
                 </a:solidFill>
@@ -20481,7 +20481,7 @@
               </a:rPr>
               <a:t>Tầng giao diện</a:t>
             </a:r>
-            <a:endParaRPr lang="en-US" sz="1800" dirty="0"/>
+            <a:endParaRPr lang="en-US" sz="1700" dirty="0"/>
           </a:p>
         </p:txBody>
       </p:sp>
@@ -20493,8 +20493,8 @@
         </p:nvSpPr>
         <p:spPr>
           <a:xfrm>
-            <a:off x="3429000" y="1664208"/>
-            <a:ext cx="8138160" cy="822960"/>
+            <a:off x="3840480" y="1664208"/>
+            <a:ext cx="7635240" cy="822960"/>
           </a:xfrm>
           <a:prstGeom prst="rect">
             <a:avLst/>
@@ -20585,7 +20585,7 @@
         <p:spPr>
           <a:xfrm>
             <a:off x="576072" y="2816352"/>
-            <a:ext cx="2651760" cy="530352"/>
+            <a:ext cx="3017520" cy="530352"/>
           </a:xfrm>
           <a:prstGeom prst="roundRect">
             <a:avLst>
@@ -20651,7 +20651,7 @@
         <p:spPr>
           <a:xfrm>
             <a:off x="1197864" y="2816352"/>
-            <a:ext cx="1993392" cy="530352"/>
+            <a:ext cx="2359152" cy="530352"/>
           </a:xfrm>
           <a:prstGeom prst="rect">
             <a:avLst/>
@@ -20672,7 +20672,7 @@
               <a:buNone/>
             </a:pPr>
             <a:r>
-              <a:rPr lang="en-US" sz="1800" b="1" dirty="0">
+              <a:rPr lang="en-US" sz="1700" b="1" dirty="0">
                 <a:solidFill>
                   <a:srgbClr val="1E2440"/>
                 </a:solidFill>
@@ -20682,7 +20682,7 @@
               </a:rPr>
               <a:t>Tầng cổng kết nối</a:t>
             </a:r>
-            <a:endParaRPr lang="en-US" sz="1800" dirty="0"/>
+            <a:endParaRPr lang="en-US" sz="1700" dirty="0"/>
           </a:p>
         </p:txBody>
       </p:sp>
@@ -20694,8 +20694,8 @@
         </p:nvSpPr>
         <p:spPr>
           <a:xfrm>
-            <a:off x="3429000" y="2688336"/>
-            <a:ext cx="8138160" cy="822960"/>
+            <a:off x="3840480" y="2688336"/>
+            <a:ext cx="7635240" cy="822960"/>
           </a:xfrm>
           <a:prstGeom prst="rect">
             <a:avLst/>
@@ -20786,7 +20786,7 @@
         <p:spPr>
           <a:xfrm>
             <a:off x="576072" y="3840480"/>
-            <a:ext cx="2651760" cy="530352"/>
+            <a:ext cx="3017520" cy="530352"/>
           </a:xfrm>
           <a:prstGeom prst="roundRect">
             <a:avLst>
@@ -20852,7 +20852,7 @@
         <p:spPr>
           <a:xfrm>
             <a:off x="1197864" y="3840480"/>
-            <a:ext cx="1993392" cy="530352"/>
+            <a:ext cx="2359152" cy="530352"/>
           </a:xfrm>
           <a:prstGeom prst="rect">
             <a:avLst/>
@@ -20873,7 +20873,7 @@
               <a:buNone/>
             </a:pPr>
             <a:r>
-              <a:rPr lang="en-US" sz="1800" b="1" dirty="0">
+              <a:rPr lang="en-US" sz="1700" b="1" dirty="0">
                 <a:solidFill>
                   <a:srgbClr val="1E2440"/>
                 </a:solidFill>
@@ -20883,7 +20883,7 @@
               </a:rPr>
               <a:t>Tầng thông minh</a:t>
             </a:r>
-            <a:endParaRPr lang="en-US" sz="1800" dirty="0"/>
+            <a:endParaRPr lang="en-US" sz="1700" dirty="0"/>
           </a:p>
         </p:txBody>
       </p:sp>
@@ -20895,8 +20895,8 @@
         </p:nvSpPr>
         <p:spPr>
           <a:xfrm>
-            <a:off x="3429000" y="3712464"/>
-            <a:ext cx="8138160" cy="822960"/>
+            <a:off x="3840480" y="3712464"/>
+            <a:ext cx="7635240" cy="822960"/>
           </a:xfrm>
           <a:prstGeom prst="rect">
             <a:avLst/>
@@ -20987,7 +20987,7 @@
         <p:spPr>
           <a:xfrm>
             <a:off x="576072" y="4864608"/>
-            <a:ext cx="2651760" cy="530352"/>
+            <a:ext cx="3017520" cy="530352"/>
           </a:xfrm>
           <a:prstGeom prst="roundRect">
             <a:avLst>
@@ -21053,7 +21053,7 @@
         <p:spPr>
           <a:xfrm>
             <a:off x="1197864" y="4864608"/>
-            <a:ext cx="1993392" cy="530352"/>
+            <a:ext cx="2359152" cy="530352"/>
           </a:xfrm>
           <a:prstGeom prst="rect">
             <a:avLst/>
@@ -21074,7 +21074,7 @@
               <a:buNone/>
             </a:pPr>
             <a:r>
-              <a:rPr lang="en-US" sz="1800" b="1" dirty="0">
+              <a:rPr lang="en-US" sz="1700" b="1" dirty="0">
                 <a:solidFill>
                   <a:srgbClr val="1E2440"/>
                 </a:solidFill>
@@ -21084,7 +21084,7 @@
               </a:rPr>
               <a:t>Tầng dữ liệu</a:t>
             </a:r>
-            <a:endParaRPr lang="en-US" sz="1800" dirty="0"/>
+            <a:endParaRPr lang="en-US" sz="1700" dirty="0"/>
           </a:p>
         </p:txBody>
       </p:sp>
@@ -21096,8 +21096,8 @@
         </p:nvSpPr>
         <p:spPr>
           <a:xfrm>
-            <a:off x="3429000" y="4736592"/>
-            <a:ext cx="8138160" cy="822960"/>
+            <a:off x="3840480" y="4736592"/>
+            <a:ext cx="7635240" cy="822960"/>
           </a:xfrm>
           <a:prstGeom prst="rect">
             <a:avLst/>
@@ -21167,8 +21167,8 @@
         </p:nvSpPr>
         <p:spPr>
           <a:xfrm>
-            <a:off x="640080" y="5779008"/>
-            <a:ext cx="10607040" cy="457200"/>
+            <a:off x="640080" y="5733288"/>
+            <a:ext cx="10607040" cy="512064"/>
           </a:xfrm>
           <a:prstGeom prst="roundRect">
             <a:avLst>
@@ -21189,8 +21189,8 @@
         </p:nvSpPr>
         <p:spPr>
           <a:xfrm>
-            <a:off x="676656" y="5769864"/>
-            <a:ext cx="420624" cy="457200"/>
+            <a:off x="676656" y="5724144"/>
+            <a:ext cx="475488" cy="512064"/>
           </a:xfrm>
           <a:prstGeom prst="rect">
             <a:avLst/>
@@ -21233,8 +21233,8 @@
         </p:nvSpPr>
         <p:spPr>
           <a:xfrm>
-            <a:off x="1188720" y="5779008"/>
-            <a:ext cx="10021824" cy="457200"/>
+            <a:off x="1243584" y="5733288"/>
+            <a:ext cx="9966960" cy="512064"/>
           </a:xfrm>
           <a:prstGeom prst="rect">
             <a:avLst/>
@@ -21263,7 +21263,7 @@
                 <a:ea typeface="Times New Roman" pitchFamily="34" charset="-122"/>
                 <a:cs typeface="Times New Roman" pitchFamily="34" charset="-120"/>
               </a:rPr>
-              <a:t>Teacher oversight + Audit log (31) + AI decision log (18) — con người quyết định cuối cùng</a:t>
+              <a:t>Oversight — giáo viên quyết định cuối cùng · Audit log (31) · AI log (18)</a:t>
             </a:r>
             <a:endParaRPr lang="en-US" sz="1600" dirty="0"/>
           </a:p>
@@ -21997,7 +21997,7 @@
                 <a:ea typeface="Times New Roman" pitchFamily="34" charset="-122"/>
                 <a:cs typeface="Times New Roman" pitchFamily="34" charset="-120"/>
               </a:rPr>
-              <a:t>Kiểm soát: schema · allow-list · range</a:t>
+              <a:t>Kiểm soát: schema · allow-list</a:t>
             </a:r>
             <a:endParaRPr lang="en-US" sz="1600" dirty="0"/>
           </a:p>
@@ -23570,7 +23570,7 @@
               <a:buNone/>
             </a:pPr>
             <a:r>
-              <a:rPr lang="en-US" sz="2000" b="1" dirty="0">
+              <a:rPr lang="en-US" sz="1600" b="1" dirty="0">
                 <a:solidFill>
                   <a:srgbClr val="1E2440"/>
                 </a:solidFill>
@@ -23578,9 +23578,9 @@
                 <a:ea typeface="Times New Roman" pitchFamily="34" charset="-122"/>
                 <a:cs typeface="Times New Roman" pitchFamily="34" charset="-120"/>
               </a:rPr>
-              <a:t>ĐỀ XUẤT THÍCH ỨNG (AI + Rule)</a:t>
-            </a:r>
-            <a:endParaRPr lang="en-US" sz="2000" dirty="0"/>
+              <a:t>ĐỀ XUẤT THÍCH ỨNG (AI)</a:t>
+            </a:r>
+            <a:endParaRPr lang="en-US" sz="1600" dirty="0"/>
           </a:p>
         </p:txBody>
       </p:sp>
@@ -23688,7 +23688,7 @@
                 <a:ea typeface="Times New Roman" pitchFamily="34" charset="-122"/>
                 <a:cs typeface="Times New Roman" pitchFamily="34" charset="-120"/>
               </a:rPr>
-              <a:t>Tình huống: Trì hoãn khởi đầu</a:t>
+              <a:t>Tình huống: Trì hoãn</a:t>
             </a:r>
             <a:endParaRPr lang="en-US" sz="1600" dirty="0"/>
           </a:p>

</xml_diff>